<commit_message>
Event delivery at 20% public and 10% private, and add PDF versions
Ratios set to the operator's own numbers. They now come from the model
rather than being repeated in prose, so the assumptions table cannot drift
from what the figures were computed on.

Effect on Geeta Govind Vatika:
- Year 1 EBITDA Rs 2.8 L -> Rs 5.6 L; year 7 margin 33.4% -> 34.3%
- Project IRR 52.4% -> 55.5%, payback 3.4 -> 3.3 years
- Minimum DSCR 1.70x -> 1.87x, debt capacity Rs 1.35 Cr -> Rs 1.51 Cr
- The cash balance floor after the year-3 reinvestment rises from
  Rs 17.3 L to Rs 25.9 L, so the build is funded with more room

Adds pdf/ — the five decks converted from the pptx, so the pack can be sent
to a lender without PowerPoint. Both are generated artefacts; README carries
the full regeneration chain from model to html, pptx and pdf.

Co-Authored-By: Claude Opus 5 <noreply@anthropic.com>
Claude-Session: https://claude.ai/code/session_01Ke6H9mZKJNe3scGWKn9ovR
</commit_message>
<xml_diff>
--- a/pptx/EOD-Company-Capital-Structure.pptx
+++ b/pptx/EOD-Company-Capital-Structure.pptx
@@ -1347,25 +1347,25 @@
                 <c:formatCode>General</c:formatCode>
                 <c:ptCount val="7"/>
                 <c:pt idx="0">
-                  <c:v>5.51</c:v>
+                  <c:v>5.53</c:v>
                 </c:pt>
                 <c:pt idx="1">
-                  <c:v>7.38</c:v>
+                  <c:v>7.42</c:v>
                 </c:pt>
                 <c:pt idx="2">
-                  <c:v>13.18</c:v>
+                  <c:v>13.22</c:v>
                 </c:pt>
                 <c:pt idx="3">
-                  <c:v>17.07</c:v>
+                  <c:v>17.11</c:v>
                 </c:pt>
                 <c:pt idx="4">
-                  <c:v>20.49</c:v>
+                  <c:v>20.54</c:v>
                 </c:pt>
                 <c:pt idx="5">
-                  <c:v>21.72</c:v>
+                  <c:v>21.77</c:v>
                 </c:pt>
                 <c:pt idx="6">
-                  <c:v>22.95</c:v>
+                  <c:v>23</c:v>
                 </c:pt>
               </c:numCache>
             </c:numRef>
@@ -10394,7 +10394,7 @@
                 <a:ea typeface="Calibri" pitchFamily="34" charset="-122"/>
                 <a:cs typeface="Calibri" pitchFamily="34" charset="-120"/>
               </a:rPr>
-              <a:t>₹20 Cr</a:t>
+              <a:t>₹21 Cr</a:t>
             </a:r>
             <a:endParaRPr lang="en-US" sz="2600" dirty="0"/>
           </a:p>
@@ -10436,7 +10436,7 @@
                 <a:ea typeface="Calibri" pitchFamily="34" charset="-122"/>
                 <a:cs typeface="Calibri" pitchFamily="34" charset="-120"/>
               </a:rPr>
-              <a:t>29.0% margin</a:t>
+              <a:t>29.1% margin</a:t>
             </a:r>
             <a:endParaRPr lang="en-US" sz="950" dirty="0"/>
           </a:p>
@@ -11122,7 +11122,7 @@
                           <a:ea typeface="Calibri" pitchFamily="34" charset="-122"/>
                           <a:cs typeface="Calibri" pitchFamily="34" charset="-120"/>
                         </a:rPr>
-                        <a:t>Enterprise value at 3.0× revenue (11× EBITDA cross-checks at ₹225 Cr)</a:t>
+                        <a:t>Enterprise value at 3.0× revenue (11× EBITDA cross-checks at ₹226 Cr)</a:t>
                       </a:r>
                       <a:endParaRPr lang="en-US" sz="1100" dirty="0">
                         <a:latin typeface="Calibri" charset="0"/>
@@ -13497,7 +13497,7 @@
                 <a:ea typeface="Calibri" pitchFamily="34" charset="-122"/>
                 <a:cs typeface="Calibri" pitchFamily="34" charset="-120"/>
               </a:rPr>
-              <a:t>2.51×</a:t>
+              <a:t>2.52×</a:t>
             </a:r>
             <a:endParaRPr lang="en-US" sz="2600" dirty="0"/>
           </a:p>

</xml_diff>